<commit_message>
fix: corrige texto em chines no PPT
</commit_message>
<xml_diff>
--- a/apresentacao.pptx
+++ b/apresentacao.pptx
@@ -4058,7 +4058,7 @@
               </a:defRPr>
             </a:pPr>
             <a:r>
-              <a:t>Crash发生在 4-8 segundos apos inicio</a:t>
+              <a:t>Crash apos 4-8 segundos do inicio</a:t>
             </a:r>
           </a:p>
           <a:p>
@@ -4791,7 +4791,7 @@
               </a:defRPr>
             </a:pPr>
             <a:r>
-              <a:t>Suzanne  -  Blender (开源, CC-BY)</a:t>
+              <a:t>Suzanne  -  Blender (open source, CC-BY)</a:t>
             </a:r>
           </a:p>
           <a:p>

</xml_diff>

<commit_message>
fix: remove Perguntas, adiciona link Tarefas-CG
</commit_message>
<xml_diff>
--- a/apresentacao.pptx
+++ b/apresentacao.pptx
@@ -5077,7 +5077,7 @@
         <p:spPr>
           <a:xfrm>
             <a:off x="914400" y="4114800"/>
-            <a:ext cx="10332720" cy="914400"/>
+            <a:ext cx="10332720" cy="548640"/>
           </a:xfrm>
           <a:prstGeom prst="rect">
             <a:avLst/>
@@ -5091,14 +5091,14 @@
           <a:lstStyle/>
           <a:p>
             <a:pPr algn="ctr">
-              <a:defRPr sz="2800" b="0">
-                <a:solidFill>
-                  <a:srgbClr val="FFFFFF"/>
-                </a:solidFill>
-              </a:defRPr>
-            </a:pPr>
-            <a:r>
-              <a:t>Perguntas?</a:t>
+              <a:defRPr sz="1800" b="0">
+                <a:solidFill>
+                  <a:srgbClr val="CCCCCC"/>
+                </a:solidFill>
+              </a:defRPr>
+            </a:pPr>
+            <a:r>
+              <a:t>Tarefas: github.com/amarqs182/Tarefas-CG</a:t>
             </a:r>
           </a:p>
         </p:txBody>

</xml_diff>